<commit_message>
Use transparent white logos on dark covers without backplates
</commit_message>
<xml_diff>
--- a/slides/00_Course_Setup_v1.4.pptx
+++ b/slides/00_Course_Setup_v1.4.pptx
@@ -8974,36 +8974,6 @@
           </a:p>
         </p:txBody>
       </p:sp>
-      <p:sp>
-        <p:nvSpPr>
-          <p:cNvPr id="10" name="Personal logo white backplate">
-            <a:extLst>
-              <a:ext uri="{FF2B5EF4-FFF2-40B4-BE49-F238E27FC236}">
-                <ns3:creationId id="{1464D463-E5BC-4BFE-BD8A-CDCFE345671F}"/>
-              </a:ext>
-            </a:extLst>
-          </p:cNvPr>
-          <p:cNvSpPr>
-            <a:spLocks noGrp="1"/>
-          </p:cNvSpPr>
-          <p:nvPr/>
-        </p:nvSpPr>
-        <p:spPr>
-          <a:xfrm>
-            <a:off x="685800" y="85725"/>
-            <a:ext cx="1714500" cy="210503"/>
-          </a:xfrm>
-          <a:prstGeom prst="rect">
-            <a:avLst/>
-          </a:prstGeom>
-          <a:solidFill>
-            <a:srgbClr val="FFFFFF"/>
-          </a:solidFill>
-          <a:ln w="0">
-            <a:noFill/>
-          </a:ln>
-        </p:spPr>
-      </p:sp>
       <p:pic>
         <p:nvPicPr>
           <p:cNvPr id="11" name=""/>
@@ -9013,7 +8983,12 @@
           <p:nvPr/>
         </p:nvPicPr>
         <p:blipFill>
-          <a:blip r:embed="rIdPersonalAuthorLogo"/>
+          <a:blip r:embed="rIdPersonalAuthorLogo">
+            <a:duotone>
+              <a:srgbClr val="FFFFFF"/>
+              <a:srgbClr val="FFFFFF"/>
+            </a:duotone>
+          </a:blip>
           <a:stretch/>
         </p:blipFill>
         <p:spPr>

</xml_diff>

<commit_message>
Reuse supplied white logo directly and match reference cover placement
</commit_message>
<xml_diff>
--- a/slides/00_Course_Setup_v1.4.pptx
+++ b/slides/00_Course_Setup_v1.4.pptx
@@ -8512,7 +8512,7 @@
 </file>
 
 <file path=ppt/slides/slide1.xml><?xml version="1.0" encoding="utf-8"?>
-<p:sld xmlns:a="http://schemas.openxmlformats.org/drawingml/2006/main" xmlns:ns3="http://schemas.microsoft.com/office/drawing/2014/main" xmlns:p="http://schemas.openxmlformats.org/presentationml/2006/main" xmlns:r="http://schemas.openxmlformats.org/officeDocument/2006/relationships">
+<p:sld xmlns:a="http://schemas.openxmlformats.org/drawingml/2006/main" xmlns:ns3="http://schemas.microsoft.com/office/drawing/2014/main" xmlns:p="http://schemas.openxmlformats.org/presentationml/2006/main" xmlns:r="http://schemas.openxmlformats.org/officeDocument/2006/relationships" showMasterSp="0">
   <p:cSld>
     <p:bg>
       <p:bgPr>
@@ -8976,25 +8976,20 @@
       </p:sp>
       <p:pic>
         <p:nvPicPr>
-          <p:cNvPr id="11" name=""/>
+          <p:cNvPr id="11" name="" descr="TSUCHIYA TAKAHIRO white logo supplied in Brandeis cover; original bytes reused"/>
           <p:cNvPicPr>
             <a:picLocks noChangeAspect="1"/>
           </p:cNvPicPr>
           <p:nvPr/>
         </p:nvPicPr>
         <p:blipFill>
-          <a:blip r:embed="rIdPersonalAuthorLogo">
-            <a:duotone>
-              <a:srgbClr val="FFFFFF"/>
-              <a:srgbClr val="FFFFFF"/>
-            </a:duotone>
-          </a:blip>
+          <a:blip r:embed="rIdPersonalAuthorLogo"/>
           <a:stretch/>
         </p:blipFill>
         <p:spPr>
           <a:xfrm>
-            <a:off x="685800" y="85748"/>
-            <a:ext cx="1714500" cy="210457"/>
+            <a:off x="3810000" y="109728"/>
+            <a:ext cx="4572000" cy="561219"/>
           </a:xfrm>
           <a:prstGeom prst="rect">
             <a:avLst/>

</xml_diff>

<commit_message>
Correct setup username guidance for updated GitHub menu
</commit_message>
<xml_diff>
--- a/slides/00_Course_Setup_v1.4.pptx
+++ b/slides/00_Course_Setup_v1.4.pptx
@@ -5437,6 +5437,14 @@
                 <a:latin typeface="Meiryo"/>
               </a:rPr>
               <a:t>Handson review 2026-10-07. Personal logo: https://tsuchiyatakahiro.com/images/logo-full.png. Screens reused from supplied v1.4/v1.3; no student-private-repository walkthrough was performed.</a:t>
+            </a:r>
+          </a:p>
+          <a:p>
+            <a:r>
+              <a:rPr lang="ja-JP" sz="1200">
+                <a:latin typeface="Meiryo"/>
+              </a:rPr>
+              <a:t>GitHub profile menu update: https://github.blog/changelog/2025-09-04-profile-menu-enhancements-in-global-navigation/ . Username reference: https://docs.github.com/en/account-and-profile/how-tos/email-preferences/remembering-your-github-username-or-email .</a:t>
             </a:r>
           </a:p>
         </p:txBody>
@@ -51306,7 +51314,7 @@
       </p:sp>
       <p:sp>
         <p:nvSpPr>
-          <p:cNvPr id="9" name="tag:Your profile"/>
+          <p:cNvPr id="9" name="tag:GitHubの右上メニュー"/>
           <p:cNvSpPr txBox="1"/>
           <p:nvPr/>
         </p:nvSpPr>
@@ -51321,8 +51329,8 @@
           <a:noFill/>
         </p:spPr>
         <p:txBody>
-          <a:bodyPr wrap="none" lIns="0" rIns="0" tIns="0" bIns="0" anchor="t">
-            <a:spAutoFit/>
+          <a:bodyPr wrap="none" lIns="0" tIns="0" rIns="0" bIns="0" anchor="t">
+            <a:noAutofit/>
           </a:bodyPr>
           <a:lstStyle/>
           <a:p>
@@ -51336,30 +51344,33 @@
               <a:spcAft>
                 <a:spcPts val="0"/>
               </a:spcAft>
+              <a:buNone/>
               <a:defRPr sz="2100" b="0">
                 <a:solidFill>
-                  <a:srgbClr val="53656D"/>
-                </a:solidFill>
-                <a:latin typeface="Meiryo"/>
+                  <a:srgbClr val="506772"/>
+                </a:solidFill>
+                <a:latin typeface="Meiryo"/>
+                <a:ea typeface="Meiryo"/>
+                <a:cs typeface="Meiryo"/>
               </a:defRPr>
             </a:pPr>
             <a:r>
               <a:rPr sz="2100" b="0">
                 <a:solidFill>
-                  <a:srgbClr val="53656D"/>
-                </a:solidFill>
-                <a:latin typeface="Meiryo"/>
-                <a:ea typeface="Meiryo"/>
-                <a:cs typeface="Meiryo"/>
-              </a:rPr>
-              <a:t>Your profile</a:t>
-            </a:r>
-          </a:p>
-        </p:txBody>
-      </p:sp>
-      <p:sp>
-        <p:nvSpPr>
-          <p:cNvPr id="10" name="tag:プロフィールのURL"/>
+                  <a:srgbClr val="506772"/>
+                </a:solidFill>
+                <a:latin typeface="Meiryo"/>
+                <a:ea typeface="Meiryo"/>
+                <a:cs typeface="Meiryo"/>
+              </a:rPr>
+              <a:t>GitHubの右上メニュー</a:t>
+            </a:r>
+          </a:p>
+        </p:txBody>
+      </p:sp>
+      <p:sp>
+        <p:nvSpPr>
+          <p:cNvPr id="10" name="tag:メニュー上部のアカウント名"/>
           <p:cNvSpPr txBox="1"/>
           <p:nvPr/>
         </p:nvSpPr>
@@ -51374,8 +51385,8 @@
           <a:noFill/>
         </p:spPr>
         <p:txBody>
-          <a:bodyPr wrap="none" lIns="0" rIns="0" tIns="0" bIns="0" anchor="t">
-            <a:spAutoFit/>
+          <a:bodyPr wrap="none" lIns="0" tIns="0" rIns="0" bIns="0" anchor="t">
+            <a:noAutofit/>
           </a:bodyPr>
           <a:lstStyle/>
           <a:p>
@@ -51389,23 +51400,26 @@
               <a:spcAft>
                 <a:spcPts val="0"/>
               </a:spcAft>
-              <a:defRPr sz="1900" b="0">
-                <a:solidFill>
-                  <a:srgbClr val="53656D"/>
-                </a:solidFill>
-                <a:latin typeface="Meiryo"/>
-              </a:defRPr>
-            </a:pPr>
-            <a:r>
-              <a:rPr sz="1900" b="0">
-                <a:solidFill>
-                  <a:srgbClr val="53656D"/>
-                </a:solidFill>
-                <a:latin typeface="Meiryo"/>
-                <a:ea typeface="Meiryo"/>
-                <a:cs typeface="Meiryo"/>
-              </a:rPr>
-              <a:t>プロフィールのURL</a:t>
+              <a:buNone/>
+              <a:defRPr sz="2000" b="0">
+                <a:solidFill>
+                  <a:srgbClr val="506772"/>
+                </a:solidFill>
+                <a:latin typeface="Meiryo"/>
+                <a:ea typeface="Meiryo"/>
+                <a:cs typeface="Meiryo"/>
+              </a:defRPr>
+            </a:pPr>
+            <a:r>
+              <a:rPr sz="2000" b="0">
+                <a:solidFill>
+                  <a:srgbClr val="506772"/>
+                </a:solidFill>
+                <a:latin typeface="Meiryo"/>
+                <a:ea typeface="Meiryo"/>
+                <a:cs typeface="Meiryo"/>
+              </a:rPr>
+              <a:t>メニュー上部のアカウント名</a:t>
             </a:r>
           </a:p>
         </p:txBody>
@@ -51457,7 +51471,7 @@
       </p:sp>
       <p:sp>
         <p:nvSpPr>
-          <p:cNvPr id="12" name="input:github.com/example-student"/>
+          <p:cNvPr id="12" name="input:example-student"/>
           <p:cNvSpPr txBox="1"/>
           <p:nvPr/>
         </p:nvSpPr>
@@ -51472,8 +51486,8 @@
           <a:noFill/>
         </p:spPr>
         <p:txBody>
-          <a:bodyPr wrap="none" lIns="0" rIns="0" tIns="0" bIns="0" anchor="t">
-            <a:spAutoFit/>
+          <a:bodyPr wrap="none" lIns="0" tIns="0" rIns="0" bIns="0" anchor="t">
+            <a:noAutofit/>
           </a:bodyPr>
           <a:lstStyle/>
           <a:p>
@@ -51487,30 +51501,33 @@
               <a:spcAft>
                 <a:spcPts val="0"/>
               </a:spcAft>
-              <a:defRPr sz="2500" b="0">
-                <a:solidFill>
-                  <a:srgbClr val="1D343E"/>
-                </a:solidFill>
-                <a:latin typeface="Meiryo"/>
-              </a:defRPr>
-            </a:pPr>
-            <a:r>
-              <a:rPr sz="2500" b="0">
-                <a:solidFill>
-                  <a:srgbClr val="1D343E"/>
-                </a:solidFill>
-                <a:latin typeface="Meiryo"/>
-                <a:ea typeface="Meiryo"/>
-                <a:cs typeface="Meiryo"/>
-              </a:rPr>
-              <a:t>github.com/example-student</a:t>
-            </a:r>
-          </a:p>
-        </p:txBody>
-      </p:sp>
-      <p:sp>
-        <p:nvSpPr>
-          <p:cNvPr id="13" name="tag:登録フォームに書く名前"/>
+              <a:buNone/>
+              <a:defRPr sz="2400" b="0">
+                <a:solidFill>
+                  <a:srgbClr val="19313D"/>
+                </a:solidFill>
+                <a:latin typeface="Meiryo"/>
+                <a:ea typeface="Meiryo"/>
+                <a:cs typeface="Meiryo"/>
+              </a:defRPr>
+            </a:pPr>
+            <a:r>
+              <a:rPr sz="2400" b="0">
+                <a:solidFill>
+                  <a:srgbClr val="19313D"/>
+                </a:solidFill>
+                <a:latin typeface="Meiryo"/>
+                <a:ea typeface="Meiryo"/>
+                <a:cs typeface="Meiryo"/>
+              </a:rPr>
+              <a:t>example-student</a:t>
+            </a:r>
+          </a:p>
+        </p:txBody>
+      </p:sp>
+      <p:sp>
+        <p:nvSpPr>
+          <p:cNvPr id="13" name="tag:プロフィールURLの例"/>
           <p:cNvSpPr txBox="1"/>
           <p:nvPr/>
         </p:nvSpPr>
@@ -51525,8 +51542,8 @@
           <a:noFill/>
         </p:spPr>
         <p:txBody>
-          <a:bodyPr wrap="none" lIns="0" rIns="0" tIns="0" bIns="0" anchor="t">
-            <a:spAutoFit/>
+          <a:bodyPr wrap="none" lIns="0" tIns="0" rIns="0" bIns="0" anchor="t">
+            <a:noAutofit/>
           </a:bodyPr>
           <a:lstStyle/>
           <a:p>
@@ -51540,23 +51557,26 @@
               <a:spcAft>
                 <a:spcPts val="0"/>
               </a:spcAft>
-              <a:defRPr sz="1900" b="0">
-                <a:solidFill>
-                  <a:srgbClr val="53656D"/>
-                </a:solidFill>
-                <a:latin typeface="Meiryo"/>
-              </a:defRPr>
-            </a:pPr>
-            <a:r>
-              <a:rPr sz="1900" b="0">
-                <a:solidFill>
-                  <a:srgbClr val="53656D"/>
-                </a:solidFill>
-                <a:latin typeface="Meiryo"/>
-                <a:ea typeface="Meiryo"/>
-                <a:cs typeface="Meiryo"/>
-              </a:rPr>
-              <a:t>登録フォームに書く名前</a:t>
+              <a:buNone/>
+              <a:defRPr sz="2000" b="0">
+                <a:solidFill>
+                  <a:srgbClr val="506772"/>
+                </a:solidFill>
+                <a:latin typeface="Meiryo"/>
+                <a:ea typeface="Meiryo"/>
+                <a:cs typeface="Meiryo"/>
+              </a:defRPr>
+            </a:pPr>
+            <a:r>
+              <a:rPr sz="2000" b="0">
+                <a:solidFill>
+                  <a:srgbClr val="506772"/>
+                </a:solidFill>
+                <a:latin typeface="Meiryo"/>
+                <a:ea typeface="Meiryo"/>
+                <a:cs typeface="Meiryo"/>
+              </a:rPr>
+              <a:t>プロフィールURLの例</a:t>
             </a:r>
           </a:p>
         </p:txBody>
@@ -51608,7 +51628,7 @@
       </p:sp>
       <p:sp>
         <p:nvSpPr>
-          <p:cNvPr id="15" name="input:example-student"/>
+          <p:cNvPr id="15" name="input:github.com/example-student"/>
           <p:cNvSpPr txBox="1"/>
           <p:nvPr/>
         </p:nvSpPr>
@@ -51623,8 +51643,8 @@
           <a:noFill/>
         </p:spPr>
         <p:txBody>
-          <a:bodyPr wrap="none" lIns="0" rIns="0" tIns="0" bIns="0" anchor="t">
-            <a:spAutoFit/>
+          <a:bodyPr wrap="none" lIns="0" tIns="0" rIns="0" bIns="0" anchor="t">
+            <a:noAutofit/>
           </a:bodyPr>
           <a:lstStyle/>
           <a:p>
@@ -51638,23 +51658,26 @@
               <a:spcAft>
                 <a:spcPts val="0"/>
               </a:spcAft>
-              <a:defRPr sz="2500" b="0">
-                <a:solidFill>
-                  <a:srgbClr val="1D343E"/>
-                </a:solidFill>
-                <a:latin typeface="Meiryo"/>
-              </a:defRPr>
-            </a:pPr>
-            <a:r>
-              <a:rPr sz="2500" b="0">
-                <a:solidFill>
-                  <a:srgbClr val="1D343E"/>
-                </a:solidFill>
-                <a:latin typeface="Meiryo"/>
-                <a:ea typeface="Meiryo"/>
-                <a:cs typeface="Meiryo"/>
-              </a:rPr>
-              <a:t>example-student</a:t>
+              <a:buNone/>
+              <a:defRPr sz="2400" b="0">
+                <a:solidFill>
+                  <a:srgbClr val="19313D"/>
+                </a:solidFill>
+                <a:latin typeface="Meiryo"/>
+                <a:ea typeface="Meiryo"/>
+                <a:cs typeface="Meiryo"/>
+              </a:defRPr>
+            </a:pPr>
+            <a:r>
+              <a:rPr sz="2400" b="0">
+                <a:solidFill>
+                  <a:srgbClr val="19313D"/>
+                </a:solidFill>
+                <a:latin typeface="Meiryo"/>
+                <a:ea typeface="Meiryo"/>
+                <a:cs typeface="Meiryo"/>
+              </a:rPr>
+              <a:t>github.com/example-student</a:t>
             </a:r>
           </a:p>
         </p:txBody>
@@ -51810,7 +51833,7 @@
       </p:sp>
       <p:sp>
         <p:nvSpPr>
-          <p:cNvPr id="19" name="body:右上からYour profile&#10;を開く。"/>
+          <p:cNvPr id="19" name="body:右上の丸い画像を&#10;押す。"/>
           <p:cNvSpPr txBox="1"/>
           <p:nvPr/>
         </p:nvSpPr>
@@ -51825,8 +51848,8 @@
           <a:noFill/>
         </p:spPr>
         <p:txBody>
-          <a:bodyPr wrap="none" lIns="0" rIns="0" tIns="0" bIns="0" anchor="t">
-            <a:spAutoFit/>
+          <a:bodyPr wrap="none" lIns="0" tIns="0" rIns="0" bIns="0" anchor="t">
+            <a:noAutofit/>
           </a:bodyPr>
           <a:lstStyle/>
           <a:p>
@@ -51840,23 +51863,26 @@
               <a:spcAft>
                 <a:spcPts val="0"/>
               </a:spcAft>
+              <a:buNone/>
               <a:defRPr sz="2500" b="1">
                 <a:solidFill>
-                  <a:srgbClr val="1D343E"/>
-                </a:solidFill>
-                <a:latin typeface="Meiryo"/>
+                  <a:srgbClr val="19313D"/>
+                </a:solidFill>
+                <a:latin typeface="Meiryo"/>
+                <a:ea typeface="Meiryo"/>
+                <a:cs typeface="Meiryo"/>
               </a:defRPr>
             </a:pPr>
             <a:r>
               <a:rPr sz="2500" b="1">
                 <a:solidFill>
-                  <a:srgbClr val="1D343E"/>
-                </a:solidFill>
-                <a:latin typeface="Meiryo"/>
-                <a:ea typeface="Meiryo"/>
-                <a:cs typeface="Meiryo"/>
-              </a:rPr>
-              <a:t>右上からYour profile</a:t>
+                  <a:srgbClr val="19313D"/>
+                </a:solidFill>
+                <a:latin typeface="Meiryo"/>
+                <a:ea typeface="Meiryo"/>
+                <a:cs typeface="Meiryo"/>
+              </a:rPr>
+              <a:t>右上の丸い画像を</a:t>
             </a:r>
           </a:p>
           <a:p>
@@ -51870,23 +51896,26 @@
               <a:spcAft>
                 <a:spcPts val="0"/>
               </a:spcAft>
+              <a:buNone/>
               <a:defRPr sz="2500" b="1">
                 <a:solidFill>
-                  <a:srgbClr val="1D343E"/>
-                </a:solidFill>
-                <a:latin typeface="Meiryo"/>
+                  <a:srgbClr val="19313D"/>
+                </a:solidFill>
+                <a:latin typeface="Meiryo"/>
+                <a:ea typeface="Meiryo"/>
+                <a:cs typeface="Meiryo"/>
               </a:defRPr>
             </a:pPr>
             <a:r>
               <a:rPr sz="2500" b="1">
                 <a:solidFill>
-                  <a:srgbClr val="1D343E"/>
-                </a:solidFill>
-                <a:latin typeface="Meiryo"/>
-                <a:ea typeface="Meiryo"/>
-                <a:cs typeface="Meiryo"/>
-              </a:rPr>
-              <a:t>を開く。</a:t>
+                  <a:srgbClr val="19313D"/>
+                </a:solidFill>
+                <a:latin typeface="Meiryo"/>
+                <a:ea typeface="Meiryo"/>
+                <a:cs typeface="Meiryo"/>
+              </a:rPr>
+              <a:t>押す。</a:t>
             </a:r>
           </a:p>
         </p:txBody>
@@ -51989,7 +52018,7 @@
       </p:sp>
       <p:sp>
         <p:nvSpPr>
-          <p:cNvPr id="22" name="body:URLの末尾が&#10;usernameです。"/>
+          <p:cNvPr id="22" name="body:メニュー上部の&#10;アカウント名を見る。"/>
           <p:cNvSpPr txBox="1"/>
           <p:nvPr/>
         </p:nvSpPr>
@@ -52004,8 +52033,8 @@
           <a:noFill/>
         </p:spPr>
         <p:txBody>
-          <a:bodyPr wrap="none" lIns="0" rIns="0" tIns="0" bIns="0" anchor="t">
-            <a:spAutoFit/>
+          <a:bodyPr wrap="none" lIns="0" tIns="0" rIns="0" bIns="0" anchor="t">
+            <a:noAutofit/>
           </a:bodyPr>
           <a:lstStyle/>
           <a:p>
@@ -52019,23 +52048,26 @@
               <a:spcAft>
                 <a:spcPts val="0"/>
               </a:spcAft>
+              <a:buNone/>
               <a:defRPr sz="2500" b="1">
                 <a:solidFill>
-                  <a:srgbClr val="1D343E"/>
-                </a:solidFill>
-                <a:latin typeface="Meiryo"/>
+                  <a:srgbClr val="19313D"/>
+                </a:solidFill>
+                <a:latin typeface="Meiryo"/>
+                <a:ea typeface="Meiryo"/>
+                <a:cs typeface="Meiryo"/>
               </a:defRPr>
             </a:pPr>
             <a:r>
               <a:rPr sz="2500" b="1">
                 <a:solidFill>
-                  <a:srgbClr val="1D343E"/>
-                </a:solidFill>
-                <a:latin typeface="Meiryo"/>
-                <a:ea typeface="Meiryo"/>
-                <a:cs typeface="Meiryo"/>
-              </a:rPr>
-              <a:t>URLの末尾が</a:t>
+                  <a:srgbClr val="19313D"/>
+                </a:solidFill>
+                <a:latin typeface="Meiryo"/>
+                <a:ea typeface="Meiryo"/>
+                <a:cs typeface="Meiryo"/>
+              </a:rPr>
+              <a:t>メニュー上部の</a:t>
             </a:r>
           </a:p>
           <a:p>
@@ -52049,23 +52081,26 @@
               <a:spcAft>
                 <a:spcPts val="0"/>
               </a:spcAft>
+              <a:buNone/>
               <a:defRPr sz="2500" b="1">
                 <a:solidFill>
-                  <a:srgbClr val="1D343E"/>
-                </a:solidFill>
-                <a:latin typeface="Meiryo"/>
+                  <a:srgbClr val="19313D"/>
+                </a:solidFill>
+                <a:latin typeface="Meiryo"/>
+                <a:ea typeface="Meiryo"/>
+                <a:cs typeface="Meiryo"/>
               </a:defRPr>
             </a:pPr>
             <a:r>
               <a:rPr sz="2500" b="1">
                 <a:solidFill>
-                  <a:srgbClr val="1D343E"/>
-                </a:solidFill>
-                <a:latin typeface="Meiryo"/>
-                <a:ea typeface="Meiryo"/>
-                <a:cs typeface="Meiryo"/>
-              </a:rPr>
-              <a:t>usernameです。</a:t>
+                  <a:srgbClr val="19313D"/>
+                </a:solidFill>
+                <a:latin typeface="Meiryo"/>
+                <a:ea typeface="Meiryo"/>
+                <a:cs typeface="Meiryo"/>
+              </a:rPr>
+              <a:t>アカウント名を見る。</a:t>
             </a:r>
           </a:p>
         </p:txBody>
@@ -52348,7 +52383,7 @@
       </p:pic>
       <p:sp>
         <p:nvSpPr>
-          <p:cNvPr id="28" name="result:表示名やメールアドレスではなく、URLの最後の名前を使います。"/>
+          <p:cNvPr id="28" name="result:登録時のUsername欄の名前です。表示名やメールとは別です。"/>
           <p:cNvSpPr txBox="1"/>
           <p:nvPr/>
         </p:nvSpPr>
@@ -52363,8 +52398,8 @@
           <a:noFill/>
         </p:spPr>
         <p:txBody>
-          <a:bodyPr wrap="none" lIns="0" rIns="0" tIns="0" bIns="0" anchor="t">
-            <a:spAutoFit/>
+          <a:bodyPr wrap="none" lIns="0" tIns="0" rIns="0" bIns="0" anchor="t">
+            <a:noAutofit/>
           </a:bodyPr>
           <a:lstStyle/>
           <a:p>
@@ -52378,23 +52413,26 @@
               <a:spcAft>
                 <a:spcPts val="0"/>
               </a:spcAft>
+              <a:buNone/>
               <a:defRPr sz="2200" b="0">
                 <a:solidFill>
-                  <a:srgbClr val="1D343E"/>
-                </a:solidFill>
-                <a:latin typeface="Meiryo"/>
+                  <a:srgbClr val="19313D"/>
+                </a:solidFill>
+                <a:latin typeface="Meiryo"/>
+                <a:ea typeface="Meiryo"/>
+                <a:cs typeface="Meiryo"/>
               </a:defRPr>
             </a:pPr>
             <a:r>
               <a:rPr sz="2200" b="0">
                 <a:solidFill>
-                  <a:srgbClr val="1D343E"/>
-                </a:solidFill>
-                <a:latin typeface="Meiryo"/>
-                <a:ea typeface="Meiryo"/>
-                <a:cs typeface="Meiryo"/>
-              </a:rPr>
-              <a:t>表示名やメールアドレスではなく、URLの最後の名前を使います。</a:t>
+                  <a:srgbClr val="19313D"/>
+                </a:solidFill>
+                <a:latin typeface="Meiryo"/>
+                <a:ea typeface="Meiryo"/>
+                <a:cs typeface="Meiryo"/>
+              </a:rPr>
+              <a:t>登録時のUsername欄の名前です。表示名やメールとは別です。</a:t>
             </a:r>
           </a:p>
         </p:txBody>

</xml_diff>

<commit_message>
Apply supplied setup slide revisions and refresh distribution set
</commit_message>
<xml_diff>
--- a/slides/00_Course_Setup_v1.4.pptx
+++ b/slides/00_Course_Setup_v1.4.pptx
@@ -17728,7 +17728,7 @@
         </p:nvSpPr>
         <p:spPr>
           <a:xfrm>
-            <a:off x="6382512" y="5047488"/>
+            <a:off x="6051588" y="5047488"/>
             <a:ext cx="365760" cy="365760"/>
           </a:xfrm>
           <a:prstGeom prst="ellipse">
@@ -17760,6 +17760,7 @@
           <a:lstStyle/>
           <a:p>
             <a:pPr algn="ctr"/>
+            <a:endParaRPr/>
           </a:p>
         </p:txBody>
       </p:sp>
@@ -17771,7 +17772,7 @@
         </p:nvSpPr>
         <p:spPr>
           <a:xfrm>
-            <a:off x="6382512" y="5070348"/>
+            <a:off x="6069002" y="5070348"/>
             <a:ext cx="365760" cy="365760"/>
           </a:xfrm>
           <a:prstGeom prst="rect">
@@ -17780,7 +17781,7 @@
           <a:noFill/>
         </p:spPr>
         <p:txBody>
-          <a:bodyPr wrap="none" lIns="0" rIns="0" tIns="0" bIns="0" anchor="t">
+          <a:bodyPr wrap="none" lIns="0" tIns="0" rIns="0" bIns="0" anchor="t">
             <a:spAutoFit/>
           </a:bodyPr>
           <a:lstStyle/>
@@ -17803,7 +17804,7 @@
               </a:defRPr>
             </a:pPr>
             <a:r>
-              <a:rPr sz="1900" b="1">
+              <a:rPr sz="1900" b="1" dirty="0">
                 <a:solidFill>
                   <a:srgbClr val="FFFFFF"/>
                 </a:solidFill>
@@ -17818,13 +17819,13 @@
       </p:sp>
       <p:sp>
         <p:nvSpPr>
-          <p:cNvPr id="15" name="body:setupでREADME.mdを見る。"/>
+          <p:cNvPr id="15" name="body:setupのREADME.mdを確認する。"/>
           <p:cNvSpPr txBox="1"/>
           <p:nvPr/>
         </p:nvSpPr>
         <p:spPr>
           <a:xfrm>
-            <a:off x="6931152" y="5038344"/>
+            <a:off x="6617642" y="5038344"/>
             <a:ext cx="4709160" cy="457200"/>
           </a:xfrm>
           <a:prstGeom prst="rect">
@@ -17859,15 +17860,37 @@
               </a:defRPr>
             </a:pPr>
             <a:r>
-              <a:rPr sz="2400" b="1">
-                <a:solidFill>
-                  <a:srgbClr val="1D343E"/>
-                </a:solidFill>
-                <a:latin typeface="Meiryo"/>
-                <a:ea typeface="Meiryo"/>
-                <a:cs typeface="Meiryo"/>
-              </a:rPr>
-              <a:t>setupのREADME.mdを見る。</a:t>
+              <a:rPr sz="2400" b="1" dirty="0" err="1">
+                <a:solidFill>
+                  <a:srgbClr val="1D343E"/>
+                </a:solidFill>
+                <a:latin typeface="Meiryo"/>
+                <a:ea typeface="Meiryo"/>
+                <a:cs typeface="Meiryo"/>
+              </a:rPr>
+              <a:t>setupのREADME.mdを</a:t>
+            </a:r>
+            <a:r>
+              <a:rPr lang="ja-JP" altLang="en-US" sz="2400" b="1" dirty="0">
+                <a:solidFill>
+                  <a:srgbClr val="1D343E"/>
+                </a:solidFill>
+                <a:latin typeface="Meiryo"/>
+                <a:ea typeface="Meiryo"/>
+                <a:cs typeface="Meiryo"/>
+              </a:rPr>
+              <a:t>確認する</a:t>
+            </a:r>
+            <a:r>
+              <a:rPr sz="2400" b="1" dirty="0">
+                <a:solidFill>
+                  <a:srgbClr val="1D343E"/>
+                </a:solidFill>
+                <a:latin typeface="Meiryo"/>
+                <a:ea typeface="Meiryo"/>
+                <a:cs typeface="Meiryo"/>
+              </a:rPr>
+              <a:t>。</a:t>
             </a:r>
           </a:p>
         </p:txBody>
@@ -38523,14 +38546,14 @@
       </p:pic>
       <p:sp>
         <p:nvSpPr>
-          <p:cNvPr id="16" name="body:大学アカウントで初回登録を送り、完了画面を見た。"/>
+          <p:cNvPr id="16" name="body:大学アカウントでGoogleform「初回登録」を回答し、完了画面を見た。"/>
           <p:cNvSpPr txBox="1"/>
           <p:nvPr/>
         </p:nvSpPr>
         <p:spPr>
           <a:xfrm>
             <a:off x="1307592" y="4590288"/>
-            <a:ext cx="10058400" cy="512064"/>
+            <a:ext cx="10946908" cy="456151"/>
           </a:xfrm>
           <a:prstGeom prst="rect">
             <a:avLst/>
@@ -38538,7 +38561,7 @@
           <a:noFill/>
         </p:spPr>
         <p:txBody>
-          <a:bodyPr wrap="none" lIns="0" rIns="0" tIns="0" bIns="0" anchor="t">
+          <a:bodyPr wrap="none" lIns="0" tIns="0" rIns="0" bIns="0" anchor="t">
             <a:spAutoFit/>
           </a:bodyPr>
           <a:lstStyle/>
@@ -38561,15 +38584,114 @@
               </a:defRPr>
             </a:pPr>
             <a:r>
-              <a:rPr sz="2600" b="0">
-                <a:solidFill>
-                  <a:srgbClr val="1D343E"/>
-                </a:solidFill>
-                <a:latin typeface="Meiryo"/>
-                <a:ea typeface="Meiryo"/>
-                <a:cs typeface="Meiryo"/>
-              </a:rPr>
-              <a:t>大学アカウントで初回登録を送り、完了画面を見た。</a:t>
+              <a:rPr sz="2600" b="0" dirty="0" err="1">
+                <a:solidFill>
+                  <a:srgbClr val="1D343E"/>
+                </a:solidFill>
+                <a:latin typeface="Meiryo"/>
+                <a:ea typeface="Meiryo"/>
+                <a:cs typeface="Meiryo"/>
+              </a:rPr>
+              <a:t>大学アカウントで</a:t>
+            </a:r>
+            <a:r>
+              <a:rPr lang="en-US" altLang="ja-JP" sz="2600" b="0" dirty="0" err="1">
+                <a:solidFill>
+                  <a:srgbClr val="1D343E"/>
+                </a:solidFill>
+                <a:latin typeface="Meiryo"/>
+                <a:ea typeface="Meiryo"/>
+                <a:cs typeface="Meiryo"/>
+              </a:rPr>
+              <a:t>Googleform</a:t>
+            </a:r>
+            <a:r>
+              <a:rPr lang="ja-JP" altLang="en-US" sz="2600" b="0" dirty="0">
+                <a:solidFill>
+                  <a:srgbClr val="1D343E"/>
+                </a:solidFill>
+                <a:latin typeface="Meiryo"/>
+                <a:ea typeface="Meiryo"/>
+                <a:cs typeface="Meiryo"/>
+              </a:rPr>
+              <a:t>「</a:t>
+            </a:r>
+            <a:r>
+              <a:rPr sz="2600" b="0" dirty="0" err="1">
+                <a:solidFill>
+                  <a:srgbClr val="1D343E"/>
+                </a:solidFill>
+                <a:latin typeface="Meiryo"/>
+                <a:ea typeface="Meiryo"/>
+                <a:cs typeface="Meiryo"/>
+              </a:rPr>
+              <a:t>初回登録</a:t>
+            </a:r>
+            <a:r>
+              <a:rPr lang="ja-JP" altLang="en-US" sz="2600" b="0" dirty="0">
+                <a:solidFill>
+                  <a:srgbClr val="1D343E"/>
+                </a:solidFill>
+                <a:latin typeface="Meiryo"/>
+                <a:ea typeface="Meiryo"/>
+                <a:cs typeface="Meiryo"/>
+              </a:rPr>
+              <a:t>」</a:t>
+            </a:r>
+            <a:r>
+              <a:rPr sz="2600" b="0" dirty="0">
+                <a:solidFill>
+                  <a:srgbClr val="1D343E"/>
+                </a:solidFill>
+                <a:latin typeface="Meiryo"/>
+                <a:ea typeface="Meiryo"/>
+                <a:cs typeface="Meiryo"/>
+              </a:rPr>
+              <a:t>を</a:t>
+            </a:r>
+            <a:r>
+              <a:rPr lang="ja-JP" altLang="en-US" sz="2600" b="0" dirty="0">
+                <a:solidFill>
+                  <a:srgbClr val="1D343E"/>
+                </a:solidFill>
+                <a:latin typeface="Meiryo"/>
+                <a:ea typeface="Meiryo"/>
+                <a:cs typeface="Meiryo"/>
+              </a:rPr>
+              <a:t>回答し</a:t>
+            </a:r>
+            <a:r>
+              <a:rPr sz="2600" b="0" dirty="0">
+                <a:solidFill>
+                  <a:srgbClr val="1D343E"/>
+                </a:solidFill>
+                <a:latin typeface="Meiryo"/>
+                <a:ea typeface="Meiryo"/>
+                <a:cs typeface="Meiryo"/>
+              </a:rPr>
+              <a:t>、</a:t>
+            </a:r>
+            <a:r>
+              <a:rPr sz="2600" b="0" dirty="0" err="1">
+                <a:solidFill>
+                  <a:srgbClr val="1D343E"/>
+                </a:solidFill>
+                <a:latin typeface="Meiryo"/>
+                <a:ea typeface="Meiryo"/>
+                <a:cs typeface="Meiryo"/>
+              </a:rPr>
+              <a:t>完了画面を見た</a:t>
+            </a:r>
+            <a:r>
+              <a:rPr sz="2600" b="0" dirty="0">
+                <a:solidFill>
+                  <a:srgbClr val="1D343E"/>
+                </a:solidFill>
+                <a:latin typeface="Meiryo"/>
+                <a:ea typeface="Meiryo"/>
+                <a:cs typeface="Meiryo"/>
+              </a:rPr>
+              <a:t>。</a:t>
             </a:r>
           </a:p>
         </p:txBody>
@@ -50298,7 +50420,7 @@
         </p:nvSpPr>
         <p:spPr>
           <a:xfrm>
-            <a:off x="749808" y="2916427"/>
+            <a:off x="749808" y="2829337"/>
             <a:ext cx="374904" cy="374904"/>
           </a:xfrm>
           <a:prstGeom prst="ellipse">
@@ -50330,6 +50452,7 @@
           <a:lstStyle/>
           <a:p>
             <a:pPr algn="ctr"/>
+            <a:endParaRPr/>
           </a:p>
         </p:txBody>
       </p:sp>
@@ -50341,7 +50464,7 @@
         </p:nvSpPr>
         <p:spPr>
           <a:xfrm>
-            <a:off x="749808" y="2939287"/>
+            <a:off x="749808" y="2869615"/>
             <a:ext cx="374904" cy="374904"/>
           </a:xfrm>
           <a:prstGeom prst="rect">
@@ -50350,7 +50473,7 @@
           <a:noFill/>
         </p:spPr>
         <p:txBody>
-          <a:bodyPr wrap="none" lIns="0" rIns="0" tIns="0" bIns="0" anchor="t">
+          <a:bodyPr wrap="none" lIns="0" tIns="0" rIns="0" bIns="0" anchor="t">
             <a:spAutoFit/>
           </a:bodyPr>
           <a:lstStyle/>
@@ -50373,7 +50496,7 @@
               </a:defRPr>
             </a:pPr>
             <a:r>
-              <a:rPr sz="1900" b="1">
+              <a:rPr sz="1900" b="1" dirty="0">
                 <a:solidFill>
                   <a:srgbClr val="FFFFFF"/>
                 </a:solidFill>
@@ -50394,7 +50517,7 @@
         </p:nvSpPr>
         <p:spPr>
           <a:xfrm>
-            <a:off x="1325880" y="2907283"/>
+            <a:off x="1325880" y="2802775"/>
             <a:ext cx="9893807" cy="459485"/>
           </a:xfrm>
           <a:prstGeom prst="rect">
@@ -50403,7 +50526,7 @@
           <a:noFill/>
         </p:spPr>
         <p:txBody>
-          <a:bodyPr wrap="none" lIns="0" rIns="0" tIns="0" bIns="0" anchor="t">
+          <a:bodyPr wrap="none" lIns="0" tIns="0" rIns="0" bIns="0" anchor="t">
             <a:spAutoFit/>
           </a:bodyPr>
           <a:lstStyle/>
@@ -50426,7 +50549,7 @@
               </a:defRPr>
             </a:pPr>
             <a:r>
-              <a:rPr sz="2700" b="1" u="sng">
+              <a:rPr sz="2700" b="1" u="sng" dirty="0">
                 <a:solidFill>
                   <a:srgbClr val="007F83"/>
                 </a:solidFill>
@@ -50435,20 +50558,44 @@
                 <a:cs typeface="Meiryo"/>
                 <a:hlinkClick r:id="rIdHandson13"/>
               </a:rPr>
-              <a:t>Emails で大学メールを追加し、確認する。</a:t>
-            </a:r>
-          </a:p>
-        </p:txBody>
-      </p:sp>
-      <p:sp>
-        <p:nvSpPr>
-          <p:cNvPr id="14" name="body:追加済みの人は、メールの確認が済んでいるか見ます。"/>
+              <a:t>Emails </a:t>
+            </a:r>
+            <a:r>
+              <a:rPr sz="2700" b="1" u="sng" dirty="0" err="1">
+                <a:solidFill>
+                  <a:srgbClr val="007F83"/>
+                </a:solidFill>
+                <a:latin typeface="Meiryo"/>
+                <a:ea typeface="Meiryo"/>
+                <a:cs typeface="Meiryo"/>
+                <a:hlinkClick r:id="rIdHandson13"/>
+              </a:rPr>
+              <a:t>で大学メールを追加し、確認する</a:t>
+            </a:r>
+            <a:r>
+              <a:rPr sz="2700" b="1" u="sng" dirty="0">
+                <a:solidFill>
+                  <a:srgbClr val="007F83"/>
+                </a:solidFill>
+                <a:latin typeface="Meiryo"/>
+                <a:ea typeface="Meiryo"/>
+                <a:cs typeface="Meiryo"/>
+                <a:hlinkClick r:id="rIdHandson13"/>
+              </a:rPr>
+              <a:t>。</a:t>
+            </a:r>
+          </a:p>
+        </p:txBody>
+      </p:sp>
+      <p:sp>
+        <p:nvSpPr>
+          <p:cNvPr id="14" name="body:Add email addressに大学メールを入力 → Add → 届いたメールで確認。※Primary email addressに大学メールが入っていれば追加の必要はなし。"/>
           <p:cNvSpPr txBox="1"/>
           <p:nvPr/>
         </p:nvSpPr>
         <p:spPr>
           <a:xfrm>
-            <a:off x="1325880" y="3430777"/>
+            <a:off x="1325880" y="3326269"/>
             <a:ext cx="9893807" cy="399542"/>
           </a:xfrm>
           <a:prstGeom prst="rect">
@@ -50483,7 +50630,7 @@
               </a:defRPr>
             </a:pPr>
             <a:r>
-              <a:rPr sz="2300" b="0">
+              <a:rPr sz="2300" b="0" dirty="0">
                 <a:solidFill>
                   <a:srgbClr val="53656D"/>
                 </a:solidFill>
@@ -50491,8 +50638,123 @@
                 <a:ea typeface="Meiryo"/>
                 <a:cs typeface="Meiryo"/>
               </a:rPr>
-              <a:t>Add email addressに大学メールを入力 → Add → 届いたメールで確認。</a:t>
-            </a:r>
+              <a:t>Add email </a:t>
+            </a:r>
+            <a:r>
+              <a:rPr sz="2300" b="0" dirty="0" err="1">
+                <a:solidFill>
+                  <a:srgbClr val="53656D"/>
+                </a:solidFill>
+                <a:latin typeface="Meiryo"/>
+                <a:ea typeface="Meiryo"/>
+                <a:cs typeface="Meiryo"/>
+              </a:rPr>
+              <a:t>addressに大学メールを入力</a:t>
+            </a:r>
+            <a:r>
+              <a:rPr sz="2300" b="0" dirty="0">
+                <a:solidFill>
+                  <a:srgbClr val="53656D"/>
+                </a:solidFill>
+                <a:latin typeface="Meiryo"/>
+                <a:ea typeface="Meiryo"/>
+                <a:cs typeface="Meiryo"/>
+              </a:rPr>
+              <a:t> → Add → </a:t>
+            </a:r>
+            <a:r>
+              <a:rPr sz="2300" b="0" dirty="0" err="1">
+                <a:solidFill>
+                  <a:srgbClr val="53656D"/>
+                </a:solidFill>
+                <a:latin typeface="Meiryo"/>
+                <a:ea typeface="Meiryo"/>
+                <a:cs typeface="Meiryo"/>
+              </a:rPr>
+              <a:t>届いたメールで確認</a:t>
+            </a:r>
+            <a:r>
+              <a:rPr sz="2300" b="0" dirty="0">
+                <a:solidFill>
+                  <a:srgbClr val="53656D"/>
+                </a:solidFill>
+                <a:latin typeface="Meiryo"/>
+                <a:ea typeface="Meiryo"/>
+                <a:cs typeface="Meiryo"/>
+              </a:rPr>
+              <a:t>。</a:t>
+            </a:r>
+            <a:endParaRPr lang="en-US" sz="2300" b="0" dirty="0">
+              <a:solidFill>
+                <a:srgbClr val="53656D"/>
+              </a:solidFill>
+              <a:latin typeface="Meiryo"/>
+              <a:ea typeface="Meiryo"/>
+              <a:cs typeface="Meiryo"/>
+            </a:endParaRPr>
+          </a:p>
+          <a:p>
+            <a:pPr>
+              <a:lnSpc>
+                <a:spcPct val="100000"/>
+              </a:lnSpc>
+              <a:spcBef>
+                <a:spcPts val="0"/>
+              </a:spcBef>
+              <a:spcAft>
+                <a:spcPts val="0"/>
+              </a:spcAft>
+              <a:buNone/>
+              <a:defRPr sz="2300" b="0">
+                <a:solidFill>
+                  <a:srgbClr val="53656D"/>
+                </a:solidFill>
+                <a:latin typeface="Meiryo"/>
+                <a:ea typeface="Meiryo"/>
+                <a:cs typeface="Meiryo"/>
+              </a:defRPr>
+            </a:pPr>
+            <a:r>
+              <a:rPr lang="en-US" altLang="ja-JP" sz="2300" b="0" dirty="0">
+                <a:solidFill>
+                  <a:srgbClr val="53656D"/>
+                </a:solidFill>
+                <a:latin typeface="Meiryo"/>
+                <a:ea typeface="Meiryo"/>
+                <a:cs typeface="Meiryo"/>
+              </a:rPr>
+              <a:t>※</a:t>
+            </a:r>
+            <a:r>
+              <a:rPr lang="en-US" sz="2300" b="0" dirty="0">
+                <a:solidFill>
+                  <a:srgbClr val="53656D"/>
+                </a:solidFill>
+                <a:latin typeface="Meiryo"/>
+                <a:ea typeface="Meiryo"/>
+                <a:cs typeface="Meiryo"/>
+              </a:rPr>
+              <a:t>Primary email address</a:t>
+            </a:r>
+            <a:r>
+              <a:rPr lang="ja-JP" altLang="en-US" sz="2300" b="0" dirty="0">
+                <a:solidFill>
+                  <a:srgbClr val="53656D"/>
+                </a:solidFill>
+                <a:latin typeface="Meiryo"/>
+                <a:ea typeface="Meiryo"/>
+                <a:cs typeface="Meiryo"/>
+              </a:rPr>
+              <a:t>に大学メールが入っていれば追加の必要はなし。</a:t>
+            </a:r>
+            <a:endParaRPr sz="2300" b="0" dirty="0">
+              <a:solidFill>
+                <a:srgbClr val="53656D"/>
+              </a:solidFill>
+              <a:latin typeface="Meiryo"/>
+              <a:ea typeface="Meiryo"/>
+              <a:cs typeface="Meiryo"/>
+            </a:endParaRPr>
           </a:p>
         </p:txBody>
       </p:sp>
@@ -50504,7 +50766,7 @@
         </p:nvSpPr>
         <p:spPr>
           <a:xfrm>
-            <a:off x="749808" y="4141215"/>
+            <a:off x="749808" y="4315395"/>
             <a:ext cx="374904" cy="374904"/>
           </a:xfrm>
           <a:prstGeom prst="ellipse">
@@ -50536,6 +50798,7 @@
           <a:lstStyle/>
           <a:p>
             <a:pPr algn="ctr"/>
+            <a:endParaRPr/>
           </a:p>
         </p:txBody>
       </p:sp>
@@ -50547,7 +50810,7 @@
         </p:nvSpPr>
         <p:spPr>
           <a:xfrm>
-            <a:off x="749808" y="4164075"/>
+            <a:off x="749808" y="4346964"/>
             <a:ext cx="374904" cy="374904"/>
           </a:xfrm>
           <a:prstGeom prst="rect">
@@ -50556,7 +50819,7 @@
           <a:noFill/>
         </p:spPr>
         <p:txBody>
-          <a:bodyPr wrap="none" lIns="0" rIns="0" tIns="0" bIns="0" anchor="t">
+          <a:bodyPr wrap="none" lIns="0" tIns="0" rIns="0" bIns="0" anchor="t">
             <a:spAutoFit/>
           </a:bodyPr>
           <a:lstStyle/>
@@ -50579,7 +50842,7 @@
               </a:defRPr>
             </a:pPr>
             <a:r>
-              <a:rPr sz="1900" b="1">
+              <a:rPr sz="1900" b="1" dirty="0">
                 <a:solidFill>
                   <a:srgbClr val="FFFFFF"/>
                 </a:solidFill>
@@ -50594,13 +50857,13 @@
       </p:sp>
       <p:sp>
         <p:nvSpPr>
-          <p:cNvPr id="17" name="body:Keep my email addresses private を確認す"/>
+          <p:cNvPr id="17" name="body:Keep my email addresses private を確認する。"/>
           <p:cNvSpPr txBox="1"/>
           <p:nvPr/>
         </p:nvSpPr>
         <p:spPr>
           <a:xfrm>
-            <a:off x="1325880" y="4132071"/>
+            <a:off x="1325880" y="4306251"/>
             <a:ext cx="9893807" cy="459485"/>
           </a:xfrm>
           <a:prstGeom prst="rect">
@@ -50609,7 +50872,7 @@
           <a:noFill/>
         </p:spPr>
         <p:txBody>
-          <a:bodyPr wrap="none" lIns="0" rIns="0" tIns="0" bIns="0" anchor="t">
+          <a:bodyPr wrap="none" lIns="0" tIns="0" rIns="0" bIns="0" anchor="t">
             <a:spAutoFit/>
           </a:bodyPr>
           <a:lstStyle/>
@@ -50632,28 +50895,50 @@
               </a:defRPr>
             </a:pPr>
             <a:r>
-              <a:rPr sz="2700" b="1">
-                <a:solidFill>
-                  <a:srgbClr val="1D343E"/>
-                </a:solidFill>
-                <a:latin typeface="Meiryo"/>
-                <a:ea typeface="Meiryo"/>
-                <a:cs typeface="Meiryo"/>
-              </a:rPr>
-              <a:t>Keep my email addresses private を確認する。</a:t>
-            </a:r>
-          </a:p>
-        </p:txBody>
-      </p:sp>
-      <p:sp>
-        <p:nvSpPr>
-          <p:cNvPr id="18" name="body:メールアドレスを公開しない設定にします。"/>
+              <a:rPr sz="2700" b="1" dirty="0">
+                <a:solidFill>
+                  <a:srgbClr val="1D343E"/>
+                </a:solidFill>
+                <a:latin typeface="Meiryo"/>
+                <a:ea typeface="Meiryo"/>
+                <a:cs typeface="Meiryo"/>
+              </a:rPr>
+              <a:t>Keep my email addresses private </a:t>
+            </a:r>
+            <a:r>
+              <a:rPr sz="2700" b="1" dirty="0" err="1">
+                <a:solidFill>
+                  <a:srgbClr val="1D343E"/>
+                </a:solidFill>
+                <a:latin typeface="Meiryo"/>
+                <a:ea typeface="Meiryo"/>
+                <a:cs typeface="Meiryo"/>
+              </a:rPr>
+              <a:t>を確認する</a:t>
+            </a:r>
+            <a:r>
+              <a:rPr sz="2700" b="1" dirty="0">
+                <a:solidFill>
+                  <a:srgbClr val="1D343E"/>
+                </a:solidFill>
+                <a:latin typeface="Meiryo"/>
+                <a:ea typeface="Meiryo"/>
+                <a:cs typeface="Meiryo"/>
+              </a:rPr>
+              <a:t>。</a:t>
+            </a:r>
+          </a:p>
+        </p:txBody>
+      </p:sp>
+      <p:sp>
+        <p:nvSpPr>
+          <p:cNvPr id="18" name="body:チェックを入れます。大学メールがVerified（確認済み）かも見ます。"/>
           <p:cNvSpPr txBox="1"/>
           <p:nvPr/>
         </p:nvSpPr>
         <p:spPr>
           <a:xfrm>
-            <a:off x="1325880" y="4655565"/>
+            <a:off x="1325880" y="4829745"/>
             <a:ext cx="9893807" cy="399542"/>
           </a:xfrm>
           <a:prstGeom prst="rect">
@@ -51314,7 +51599,7 @@
       </p:sp>
       <p:sp>
         <p:nvSpPr>
-          <p:cNvPr id="9" name="tag:GitHubの右上メニュー"/>
+          <p:cNvPr id="9" name="tag:Profile"/>
           <p:cNvSpPr txBox="1"/>
           <p:nvPr/>
         </p:nvSpPr>
@@ -51363,14 +51648,14 @@
                 <a:ea typeface="Meiryo"/>
                 <a:cs typeface="Meiryo"/>
               </a:rPr>
-              <a:t>GitHubの右上メニュー</a:t>
-            </a:r>
-          </a:p>
-        </p:txBody>
-      </p:sp>
-      <p:sp>
-        <p:nvSpPr>
-          <p:cNvPr id="10" name="tag:メニュー上部のアカウント名"/>
+              <a:t>Profile</a:t>
+            </a:r>
+          </a:p>
+        </p:txBody>
+      </p:sp>
+      <p:sp>
+        <p:nvSpPr>
+          <p:cNvPr id="10" name="tag:プロフィールのURL"/>
           <p:cNvSpPr txBox="1"/>
           <p:nvPr/>
         </p:nvSpPr>
@@ -51386,7 +51671,7 @@
         </p:spPr>
         <p:txBody>
           <a:bodyPr wrap="none" lIns="0" tIns="0" rIns="0" bIns="0" anchor="t">
-            <a:noAutofit/>
+            <a:spAutoFit/>
           </a:bodyPr>
           <a:lstStyle/>
           <a:p>
@@ -51400,26 +51685,23 @@
               <a:spcAft>
                 <a:spcPts val="0"/>
               </a:spcAft>
-              <a:buNone/>
-              <a:defRPr sz="2000" b="0">
-                <a:solidFill>
-                  <a:srgbClr val="506772"/>
-                </a:solidFill>
-                <a:latin typeface="Meiryo"/>
-                <a:ea typeface="Meiryo"/>
-                <a:cs typeface="Meiryo"/>
-              </a:defRPr>
-            </a:pPr>
-            <a:r>
-              <a:rPr sz="2000" b="0">
-                <a:solidFill>
-                  <a:srgbClr val="506772"/>
-                </a:solidFill>
-                <a:latin typeface="Meiryo"/>
-                <a:ea typeface="Meiryo"/>
-                <a:cs typeface="Meiryo"/>
-              </a:rPr>
-              <a:t>メニュー上部のアカウント名</a:t>
+              <a:defRPr sz="1900" b="0">
+                <a:solidFill>
+                  <a:srgbClr val="53656D"/>
+                </a:solidFill>
+                <a:latin typeface="Meiryo"/>
+              </a:defRPr>
+            </a:pPr>
+            <a:r>
+              <a:rPr sz="1900" b="0">
+                <a:solidFill>
+                  <a:srgbClr val="53656D"/>
+                </a:solidFill>
+                <a:latin typeface="Meiryo"/>
+                <a:ea typeface="Meiryo"/>
+                <a:cs typeface="Meiryo"/>
+              </a:rPr>
+              <a:t>プロフィールのURL</a:t>
             </a:r>
           </a:p>
         </p:txBody>
@@ -51471,7 +51753,7 @@
       </p:sp>
       <p:sp>
         <p:nvSpPr>
-          <p:cNvPr id="12" name="input:example-student"/>
+          <p:cNvPr id="12" name="input:github.com/example-student"/>
           <p:cNvSpPr txBox="1"/>
           <p:nvPr/>
         </p:nvSpPr>
@@ -51487,7 +51769,7 @@
         </p:spPr>
         <p:txBody>
           <a:bodyPr wrap="none" lIns="0" tIns="0" rIns="0" bIns="0" anchor="t">
-            <a:noAutofit/>
+            <a:spAutoFit/>
           </a:bodyPr>
           <a:lstStyle/>
           <a:p>
@@ -51501,33 +51783,30 @@
               <a:spcAft>
                 <a:spcPts val="0"/>
               </a:spcAft>
-              <a:buNone/>
-              <a:defRPr sz="2400" b="0">
-                <a:solidFill>
-                  <a:srgbClr val="19313D"/>
-                </a:solidFill>
-                <a:latin typeface="Meiryo"/>
-                <a:ea typeface="Meiryo"/>
-                <a:cs typeface="Meiryo"/>
-              </a:defRPr>
-            </a:pPr>
-            <a:r>
-              <a:rPr sz="2400" b="0">
-                <a:solidFill>
-                  <a:srgbClr val="19313D"/>
-                </a:solidFill>
-                <a:latin typeface="Meiryo"/>
-                <a:ea typeface="Meiryo"/>
-                <a:cs typeface="Meiryo"/>
-              </a:rPr>
-              <a:t>example-student</a:t>
-            </a:r>
-          </a:p>
-        </p:txBody>
-      </p:sp>
-      <p:sp>
-        <p:nvSpPr>
-          <p:cNvPr id="13" name="tag:プロフィールURLの例"/>
+              <a:defRPr sz="2500" b="0">
+                <a:solidFill>
+                  <a:srgbClr val="1D343E"/>
+                </a:solidFill>
+                <a:latin typeface="Meiryo"/>
+              </a:defRPr>
+            </a:pPr>
+            <a:r>
+              <a:rPr sz="2500" b="0">
+                <a:solidFill>
+                  <a:srgbClr val="1D343E"/>
+                </a:solidFill>
+                <a:latin typeface="Meiryo"/>
+                <a:ea typeface="Meiryo"/>
+                <a:cs typeface="Meiryo"/>
+              </a:rPr>
+              <a:t>github.com/example-student</a:t>
+            </a:r>
+          </a:p>
+        </p:txBody>
+      </p:sp>
+      <p:sp>
+        <p:nvSpPr>
+          <p:cNvPr id="13" name="tag:登録フォームに書く名前"/>
           <p:cNvSpPr txBox="1"/>
           <p:nvPr/>
         </p:nvSpPr>
@@ -51543,7 +51822,7 @@
         </p:spPr>
         <p:txBody>
           <a:bodyPr wrap="none" lIns="0" tIns="0" rIns="0" bIns="0" anchor="t">
-            <a:noAutofit/>
+            <a:spAutoFit/>
           </a:bodyPr>
           <a:lstStyle/>
           <a:p>
@@ -51557,26 +51836,23 @@
               <a:spcAft>
                 <a:spcPts val="0"/>
               </a:spcAft>
-              <a:buNone/>
-              <a:defRPr sz="2000" b="0">
-                <a:solidFill>
-                  <a:srgbClr val="506772"/>
-                </a:solidFill>
-                <a:latin typeface="Meiryo"/>
-                <a:ea typeface="Meiryo"/>
-                <a:cs typeface="Meiryo"/>
-              </a:defRPr>
-            </a:pPr>
-            <a:r>
-              <a:rPr sz="2000" b="0">
-                <a:solidFill>
-                  <a:srgbClr val="506772"/>
-                </a:solidFill>
-                <a:latin typeface="Meiryo"/>
-                <a:ea typeface="Meiryo"/>
-                <a:cs typeface="Meiryo"/>
-              </a:rPr>
-              <a:t>プロフィールURLの例</a:t>
+              <a:defRPr sz="1900" b="0">
+                <a:solidFill>
+                  <a:srgbClr val="53656D"/>
+                </a:solidFill>
+                <a:latin typeface="Meiryo"/>
+              </a:defRPr>
+            </a:pPr>
+            <a:r>
+              <a:rPr sz="1900" b="0">
+                <a:solidFill>
+                  <a:srgbClr val="53656D"/>
+                </a:solidFill>
+                <a:latin typeface="Meiryo"/>
+                <a:ea typeface="Meiryo"/>
+                <a:cs typeface="Meiryo"/>
+              </a:rPr>
+              <a:t>登録フォームに書く名前</a:t>
             </a:r>
           </a:p>
         </p:txBody>
@@ -51628,7 +51904,7 @@
       </p:sp>
       <p:sp>
         <p:nvSpPr>
-          <p:cNvPr id="15" name="input:github.com/example-student"/>
+          <p:cNvPr id="15" name="input:example-student"/>
           <p:cNvSpPr txBox="1"/>
           <p:nvPr/>
         </p:nvSpPr>
@@ -51644,7 +51920,7 @@
         </p:spPr>
         <p:txBody>
           <a:bodyPr wrap="none" lIns="0" tIns="0" rIns="0" bIns="0" anchor="t">
-            <a:noAutofit/>
+            <a:spAutoFit/>
           </a:bodyPr>
           <a:lstStyle/>
           <a:p>
@@ -51658,26 +51934,23 @@
               <a:spcAft>
                 <a:spcPts val="0"/>
               </a:spcAft>
-              <a:buNone/>
-              <a:defRPr sz="2400" b="0">
-                <a:solidFill>
-                  <a:srgbClr val="19313D"/>
-                </a:solidFill>
-                <a:latin typeface="Meiryo"/>
-                <a:ea typeface="Meiryo"/>
-                <a:cs typeface="Meiryo"/>
-              </a:defRPr>
-            </a:pPr>
-            <a:r>
-              <a:rPr sz="2400" b="0">
-                <a:solidFill>
-                  <a:srgbClr val="19313D"/>
-                </a:solidFill>
-                <a:latin typeface="Meiryo"/>
-                <a:ea typeface="Meiryo"/>
-                <a:cs typeface="Meiryo"/>
-              </a:rPr>
-              <a:t>github.com/example-student</a:t>
+              <a:defRPr sz="2500" b="0">
+                <a:solidFill>
+                  <a:srgbClr val="1D343E"/>
+                </a:solidFill>
+                <a:latin typeface="Meiryo"/>
+              </a:defRPr>
+            </a:pPr>
+            <a:r>
+              <a:rPr sz="2500" b="0">
+                <a:solidFill>
+                  <a:srgbClr val="1D343E"/>
+                </a:solidFill>
+                <a:latin typeface="Meiryo"/>
+                <a:ea typeface="Meiryo"/>
+                <a:cs typeface="Meiryo"/>
+              </a:rPr>
+              <a:t>example-student</a:t>
             </a:r>
           </a:p>
         </p:txBody>
@@ -51833,14 +52106,14 @@
       </p:sp>
       <p:sp>
         <p:nvSpPr>
-          <p:cNvPr id="19" name="body:右上の丸い画像を&#10;押す。"/>
+          <p:cNvPr id="19" name="body:右上からProfileを開く。"/>
           <p:cNvSpPr txBox="1"/>
           <p:nvPr/>
         </p:nvSpPr>
         <p:spPr>
           <a:xfrm>
-            <a:off x="7982712" y="1719072"/>
-            <a:ext cx="3557015" cy="804164"/>
+            <a:off x="7982711" y="1719072"/>
+            <a:ext cx="3678065" cy="438582"/>
           </a:xfrm>
           <a:prstGeom prst="rect">
             <a:avLst/>
@@ -51848,7 +52121,7 @@
           <a:noFill/>
         </p:spPr>
         <p:txBody>
-          <a:bodyPr wrap="none" lIns="0" tIns="0" rIns="0" bIns="0" anchor="t">
+          <a:bodyPr wrap="square" lIns="0" tIns="0" rIns="0" bIns="0" anchor="t">
             <a:noAutofit/>
           </a:bodyPr>
           <a:lstStyle/>
@@ -51882,40 +52155,7 @@
                 <a:ea typeface="Meiryo"/>
                 <a:cs typeface="Meiryo"/>
               </a:rPr>
-              <a:t>右上の丸い画像を</a:t>
-            </a:r>
-          </a:p>
-          <a:p>
-            <a:pPr>
-              <a:lnSpc>
-                <a:spcPct val="114000"/>
-              </a:lnSpc>
-              <a:spcBef>
-                <a:spcPts val="0"/>
-              </a:spcBef>
-              <a:spcAft>
-                <a:spcPts val="0"/>
-              </a:spcAft>
-              <a:buNone/>
-              <a:defRPr sz="2500" b="1">
-                <a:solidFill>
-                  <a:srgbClr val="19313D"/>
-                </a:solidFill>
-                <a:latin typeface="Meiryo"/>
-                <a:ea typeface="Meiryo"/>
-                <a:cs typeface="Meiryo"/>
-              </a:defRPr>
-            </a:pPr>
-            <a:r>
-              <a:rPr sz="2500" b="1">
-                <a:solidFill>
-                  <a:srgbClr val="19313D"/>
-                </a:solidFill>
-                <a:latin typeface="Meiryo"/>
-                <a:ea typeface="Meiryo"/>
-                <a:cs typeface="Meiryo"/>
-              </a:rPr>
-              <a:t>押す。</a:t>
+              <a:t>右上からProfileを開く。</a:t>
             </a:r>
           </a:p>
         </p:txBody>
@@ -51928,7 +52168,7 @@
         </p:nvSpPr>
         <p:spPr>
           <a:xfrm>
-            <a:off x="7406640" y="2806700"/>
+            <a:off x="7406640" y="2564653"/>
             <a:ext cx="374904" cy="374904"/>
           </a:xfrm>
           <a:prstGeom prst="ellipse">
@@ -51960,6 +52200,7 @@
           <a:lstStyle/>
           <a:p>
             <a:pPr algn="ctr"/>
+            <a:endParaRPr/>
           </a:p>
         </p:txBody>
       </p:sp>
@@ -51971,7 +52212,7 @@
         </p:nvSpPr>
         <p:spPr>
           <a:xfrm>
-            <a:off x="7406640" y="2829559"/>
+            <a:off x="7406640" y="2587512"/>
             <a:ext cx="374904" cy="374904"/>
           </a:xfrm>
           <a:prstGeom prst="rect">
@@ -51980,7 +52221,7 @@
           <a:noFill/>
         </p:spPr>
         <p:txBody>
-          <a:bodyPr wrap="none" lIns="0" rIns="0" tIns="0" bIns="0" anchor="t">
+          <a:bodyPr wrap="none" lIns="0" tIns="0" rIns="0" bIns="0" anchor="t">
             <a:spAutoFit/>
           </a:bodyPr>
           <a:lstStyle/>
@@ -52018,14 +52259,14 @@
       </p:sp>
       <p:sp>
         <p:nvSpPr>
-          <p:cNvPr id="22" name="body:メニュー上部の&#10;アカウント名を見る。"/>
+          <p:cNvPr id="22" name="body:URLの末尾がusernameであることを確認します。"/>
           <p:cNvSpPr txBox="1"/>
           <p:nvPr/>
         </p:nvSpPr>
         <p:spPr>
           <a:xfrm>
-            <a:off x="7982712" y="2797556"/>
-            <a:ext cx="3557015" cy="804164"/>
+            <a:off x="7982712" y="2555509"/>
+            <a:ext cx="3614772" cy="1315745"/>
           </a:xfrm>
           <a:prstGeom prst="rect">
             <a:avLst/>
@@ -52034,7 +52275,7 @@
         </p:spPr>
         <p:txBody>
           <a:bodyPr wrap="none" lIns="0" tIns="0" rIns="0" bIns="0" anchor="t">
-            <a:noAutofit/>
+            <a:spAutoFit/>
           </a:bodyPr>
           <a:lstStyle/>
           <a:p>
@@ -52048,27 +52289,32 @@
               <a:spcAft>
                 <a:spcPts val="0"/>
               </a:spcAft>
-              <a:buNone/>
               <a:defRPr sz="2500" b="1">
                 <a:solidFill>
-                  <a:srgbClr val="19313D"/>
-                </a:solidFill>
-                <a:latin typeface="Meiryo"/>
-                <a:ea typeface="Meiryo"/>
-                <a:cs typeface="Meiryo"/>
-              </a:defRPr>
-            </a:pPr>
-            <a:r>
-              <a:rPr sz="2500" b="1">
-                <a:solidFill>
-                  <a:srgbClr val="19313D"/>
-                </a:solidFill>
-                <a:latin typeface="Meiryo"/>
-                <a:ea typeface="Meiryo"/>
-                <a:cs typeface="Meiryo"/>
-              </a:rPr>
-              <a:t>メニュー上部の</a:t>
-            </a:r>
+                  <a:srgbClr val="1D343E"/>
+                </a:solidFill>
+                <a:latin typeface="Meiryo"/>
+              </a:defRPr>
+            </a:pPr>
+            <a:r>
+              <a:rPr sz="2500" b="1" dirty="0" err="1">
+                <a:solidFill>
+                  <a:srgbClr val="1D343E"/>
+                </a:solidFill>
+                <a:latin typeface="Meiryo"/>
+                <a:ea typeface="Meiryo"/>
+                <a:cs typeface="Meiryo"/>
+              </a:rPr>
+              <a:t>URLの末尾が</a:t>
+            </a:r>
+            <a:endParaRPr sz="2500" b="1" dirty="0">
+              <a:solidFill>
+                <a:srgbClr val="1D343E"/>
+              </a:solidFill>
+              <a:latin typeface="Meiryo"/>
+              <a:ea typeface="Meiryo"/>
+              <a:cs typeface="Meiryo"/>
+            </a:endParaRPr>
           </a:p>
           <a:p>
             <a:pPr>
@@ -52081,26 +52327,83 @@
               <a:spcAft>
                 <a:spcPts val="0"/>
               </a:spcAft>
-              <a:buNone/>
               <a:defRPr sz="2500" b="1">
                 <a:solidFill>
-                  <a:srgbClr val="19313D"/>
-                </a:solidFill>
-                <a:latin typeface="Meiryo"/>
-                <a:ea typeface="Meiryo"/>
-                <a:cs typeface="Meiryo"/>
-              </a:defRPr>
-            </a:pPr>
-            <a:r>
-              <a:rPr sz="2500" b="1">
-                <a:solidFill>
-                  <a:srgbClr val="19313D"/>
-                </a:solidFill>
-                <a:latin typeface="Meiryo"/>
-                <a:ea typeface="Meiryo"/>
-                <a:cs typeface="Meiryo"/>
-              </a:rPr>
-              <a:t>アカウント名を見る。</a:t>
+                  <a:srgbClr val="1D343E"/>
+                </a:solidFill>
+                <a:latin typeface="Meiryo"/>
+              </a:defRPr>
+            </a:pPr>
+            <a:r>
+              <a:rPr sz="2500" b="1" dirty="0" err="1">
+                <a:solidFill>
+                  <a:srgbClr val="1D343E"/>
+                </a:solidFill>
+                <a:latin typeface="Meiryo"/>
+                <a:ea typeface="Meiryo"/>
+                <a:cs typeface="Meiryo"/>
+              </a:rPr>
+              <a:t>usernameで</a:t>
+            </a:r>
+            <a:r>
+              <a:rPr lang="ja-JP" altLang="en-US" sz="2500" b="1" dirty="0">
+                <a:solidFill>
+                  <a:srgbClr val="1D343E"/>
+                </a:solidFill>
+                <a:latin typeface="Meiryo"/>
+                <a:ea typeface="Meiryo"/>
+                <a:cs typeface="Meiryo"/>
+              </a:rPr>
+              <a:t>あることを</a:t>
+            </a:r>
+            <a:endParaRPr lang="en-US" altLang="ja-JP" sz="2500" b="1" dirty="0">
+              <a:solidFill>
+                <a:srgbClr val="1D343E"/>
+              </a:solidFill>
+              <a:latin typeface="Meiryo"/>
+              <a:ea typeface="Meiryo"/>
+              <a:cs typeface="Meiryo"/>
+            </a:endParaRPr>
+          </a:p>
+          <a:p>
+            <a:pPr>
+              <a:lnSpc>
+                <a:spcPct val="114000"/>
+              </a:lnSpc>
+              <a:spcBef>
+                <a:spcPts val="0"/>
+              </a:spcBef>
+              <a:spcAft>
+                <a:spcPts val="0"/>
+              </a:spcAft>
+              <a:defRPr sz="2500" b="1">
+                <a:solidFill>
+                  <a:srgbClr val="1D343E"/>
+                </a:solidFill>
+                <a:latin typeface="Meiryo"/>
+              </a:defRPr>
+            </a:pPr>
+            <a:r>
+              <a:rPr lang="ja-JP" altLang="en-US" sz="2500" b="1" dirty="0">
+                <a:solidFill>
+                  <a:srgbClr val="1D343E"/>
+                </a:solidFill>
+                <a:latin typeface="Meiryo"/>
+                <a:ea typeface="Meiryo"/>
+                <a:cs typeface="Meiryo"/>
+              </a:rPr>
+              <a:t>確認します</a:t>
+            </a:r>
+            <a:r>
+              <a:rPr sz="2500" b="1" dirty="0">
+                <a:solidFill>
+                  <a:srgbClr val="1D343E"/>
+                </a:solidFill>
+                <a:latin typeface="Meiryo"/>
+                <a:ea typeface="Meiryo"/>
+                <a:cs typeface="Meiryo"/>
+              </a:rPr>
+              <a:t>。</a:t>
             </a:r>
           </a:p>
         </p:txBody>
@@ -52383,7 +52686,7 @@
       </p:pic>
       <p:sp>
         <p:nvSpPr>
-          <p:cNvPr id="28" name="result:登録時のUsername欄の名前です。表示名やメールとは別です。"/>
+          <p:cNvPr id="28" name="result:表示名やメールアドレスではなく、URLの最後の名前を使います。"/>
           <p:cNvSpPr txBox="1"/>
           <p:nvPr/>
         </p:nvSpPr>
@@ -52399,7 +52702,7 @@
         </p:spPr>
         <p:txBody>
           <a:bodyPr wrap="none" lIns="0" tIns="0" rIns="0" bIns="0" anchor="t">
-            <a:noAutofit/>
+            <a:spAutoFit/>
           </a:bodyPr>
           <a:lstStyle/>
           <a:p>
@@ -52413,26 +52716,23 @@
               <a:spcAft>
                 <a:spcPts val="0"/>
               </a:spcAft>
-              <a:buNone/>
               <a:defRPr sz="2200" b="0">
                 <a:solidFill>
-                  <a:srgbClr val="19313D"/>
-                </a:solidFill>
-                <a:latin typeface="Meiryo"/>
-                <a:ea typeface="Meiryo"/>
-                <a:cs typeface="Meiryo"/>
+                  <a:srgbClr val="1D343E"/>
+                </a:solidFill>
+                <a:latin typeface="Meiryo"/>
               </a:defRPr>
             </a:pPr>
             <a:r>
               <a:rPr sz="2200" b="0">
                 <a:solidFill>
-                  <a:srgbClr val="19313D"/>
-                </a:solidFill>
-                <a:latin typeface="Meiryo"/>
-                <a:ea typeface="Meiryo"/>
-                <a:cs typeface="Meiryo"/>
-              </a:rPr>
-              <a:t>登録時のUsername欄の名前です。表示名やメールとは別です。</a:t>
+                  <a:srgbClr val="1D343E"/>
+                </a:solidFill>
+                <a:latin typeface="Meiryo"/>
+                <a:ea typeface="Meiryo"/>
+                <a:cs typeface="Meiryo"/>
+              </a:rPr>
+              <a:t>表示名やメールアドレスではなく、URLの最後の名前を使います。</a:t>
             </a:r>
           </a:p>
         </p:txBody>

</xml_diff>

<commit_message>
Make teacher invitation instructions reusable across courses
</commit_message>
<xml_diff>
--- a/slides/00_Course_Setup_v1.4.pptx
+++ b/slides/00_Course_Setup_v1.4.pptx
@@ -30721,7 +30721,7 @@
 </file>
 
 <file path=ppt/slides/slide27.xml><?xml version="1.0" encoding="utf-8"?>
-<p:sld xmlns:a="http://schemas.openxmlformats.org/drawingml/2006/main" xmlns:p="http://schemas.openxmlformats.org/presentationml/2006/main" xmlns:r="http://schemas.openxmlformats.org/officeDocument/2006/relationships">
+<p:sld xmlns:a="http://schemas.openxmlformats.org/drawingml/2006/main" xmlns:ns3="http://schemas.microsoft.com/office/drawing/2014/main" xmlns:p="http://schemas.openxmlformats.org/presentationml/2006/main" xmlns:r="http://schemas.openxmlformats.org/officeDocument/2006/relationships">
   <p:cSld>
     <p:bg>
       <p:bgPr>
@@ -30836,7 +30836,7 @@
       </p:sp>
       <p:sp>
         <p:nvSpPr>
-          <p:cNvPr id="4" name="title:tsuchiyatakahirolabを教員として招待する"/>
+          <p:cNvPr id="4" name="title:教員のアカウントを招待する"/>
           <p:cNvSpPr txBox="1"/>
           <p:nvPr/>
         </p:nvSpPr>
@@ -30851,7 +30851,7 @@
           <a:noFill/>
         </p:spPr>
         <p:txBody>
-          <a:bodyPr wrap="none" lIns="0" rIns="0" tIns="0" bIns="0" anchor="t">
+          <a:bodyPr wrap="none" lIns="0" tIns="0" rIns="0" bIns="0" anchor="t">
             <a:spAutoFit/>
           </a:bodyPr>
           <a:lstStyle/>
@@ -30866,11 +30866,14 @@
               <a:spcAft>
                 <a:spcPts val="0"/>
               </a:spcAft>
+              <a:buNone/>
               <a:defRPr sz="3400" b="1">
                 <a:solidFill>
                   <a:srgbClr val="1D343E"/>
                 </a:solidFill>
                 <a:latin typeface="Meiryo"/>
+                <a:ea typeface="Meiryo"/>
+                <a:cs typeface="Meiryo"/>
               </a:defRPr>
             </a:pPr>
             <a:r>
@@ -30882,7 +30885,7 @@
                 <a:ea typeface="Meiryo"/>
                 <a:cs typeface="Meiryo"/>
               </a:rPr>
-              <a:t>tsuchiyatakahirolabを教員として招待する</a:t>
+              <a:t>教員のアカウントを招待する</a:t>
             </a:r>
           </a:p>
         </p:txBody>
@@ -31248,7 +31251,7 @@
       </p:sp>
       <p:sp>
         <p:nvSpPr>
-          <p:cNvPr id="13" name="tag:招待するusername"/>
+          <p:cNvPr id="13" name="tag:招待するusername（この授業の教員）"/>
           <p:cNvSpPr txBox="1"/>
           <p:nvPr/>
         </p:nvSpPr>
@@ -31263,7 +31266,7 @@
           <a:noFill/>
         </p:spPr>
         <p:txBody>
-          <a:bodyPr wrap="none" lIns="0" rIns="0" tIns="0" bIns="0" anchor="t">
+          <a:bodyPr wrap="none" lIns="0" tIns="0" rIns="0" bIns="0" anchor="t">
             <a:spAutoFit/>
           </a:bodyPr>
           <a:lstStyle/>
@@ -31278,11 +31281,14 @@
               <a:spcAft>
                 <a:spcPts val="0"/>
               </a:spcAft>
+              <a:buNone/>
               <a:defRPr sz="1900" b="0">
                 <a:solidFill>
                   <a:srgbClr val="53656D"/>
                 </a:solidFill>
                 <a:latin typeface="Meiryo"/>
+                <a:ea typeface="Meiryo"/>
+                <a:cs typeface="Meiryo"/>
               </a:defRPr>
             </a:pPr>
             <a:r>
@@ -31294,7 +31300,7 @@
                 <a:ea typeface="Meiryo"/>
                 <a:cs typeface="Meiryo"/>
               </a:rPr>
-              <a:t>招待するusername</a:t>
+              <a:t>招待するusername（この授業の教員）</a:t>
             </a:r>
           </a:p>
         </p:txBody>
@@ -32279,6 +32285,86 @@
                 <a:cs typeface="Meiryo"/>
               </a:rPr>
               <a:t>27 / 37</a:t>
+            </a:r>
+          </a:p>
+        </p:txBody>
+      </p:sp>
+      <p:sp>
+        <p:nvSpPr>
+          <p:cNvPr id="32" name="teacher-username-reuse-note">
+            <a:extLst>
+              <a:ext uri="{FF2B5EF4-FFF2-40B4-BE49-F238E27FC236}">
+                <ns3:creationId id="{7EF6D775-B802-492E-A8A0-045D7CDE2182}"/>
+              </a:ext>
+            </a:extLst>
+          </p:cNvPr>
+          <p:cNvSpPr>
+            <a:spLocks noGrp="1"/>
+          </p:cNvSpPr>
+          <p:nvPr/>
+        </p:nvSpPr>
+        <p:spPr>
+          <a:xfrm>
+            <a:off x="841248" y="4552950"/>
+            <a:ext cx="6071616" cy="628650"/>
+          </a:xfrm>
+          <a:prstGeom prst="rect">
+            <a:avLst/>
+          </a:prstGeom>
+          <a:noFill/>
+          <a:ln w="0">
+            <a:noFill/>
+          </a:ln>
+        </p:spPr>
+        <p:txBody>
+          <a:bodyPr>
+            <a:noAutofit/>
+          </a:bodyPr>
+          <a:lstStyle/>
+          <a:p>
+            <a:pPr>
+              <a:defRPr sz="1800">
+                <a:solidFill>
+                  <a:srgbClr val="506772"/>
+                </a:solidFill>
+                <a:latin typeface="Meiryo"/>
+                <a:ea typeface="Meiryo"/>
+                <a:cs typeface="Meiryo"/>
+              </a:defRPr>
+            </a:pPr>
+            <a:r>
+              <a:rPr sz="1800">
+                <a:solidFill>
+                  <a:srgbClr val="506772"/>
+                </a:solidFill>
+                <a:latin typeface="Meiryo"/>
+                <a:ea typeface="Meiryo"/>
+                <a:cs typeface="Meiryo"/>
+              </a:rPr>
+              <a:t>別の授業では、招待先を担当教員の</a:t>
+            </a:r>
+          </a:p>
+          <a:p>
+            <a:pPr>
+              <a:defRPr sz="1800">
+                <a:solidFill>
+                  <a:srgbClr val="506772"/>
+                </a:solidFill>
+                <a:latin typeface="Meiryo"/>
+                <a:ea typeface="Meiryo"/>
+                <a:cs typeface="Meiryo"/>
+              </a:defRPr>
+            </a:pPr>
+            <a:r>
+              <a:rPr sz="1800">
+                <a:solidFill>
+                  <a:srgbClr val="506772"/>
+                </a:solidFill>
+                <a:latin typeface="Meiryo"/>
+                <a:ea typeface="Meiryo"/>
+                <a:cs typeface="Meiryo"/>
+              </a:rPr>
+              <a:t>usernameに差し替えます。</a:t>
             </a:r>
           </a:p>
         </p:txBody>

</xml_diff>